<commit_message>
feat(research): add live tool-driven market research and refresh
</commit_message>
<xml_diff>
--- a/deliverables/london-office-market-agent.pptx
+++ b/deliverables/london-office-market-agent.pptx
@@ -3130,7 +3130,7 @@
                 </a:solidFill>
                 <a:latin typeface="Aptos"/>
               </a:rPr>
-              <a:t>LONDON MARKET MONITOR  /  THE BRIEF  ·  DEMO DATA</a:t>
+              <a:t>LONDON MARKET MONITOR  /  THE DECISION  ·  LIVE RESEARCH</a:t>
             </a:r>
           </a:p>
         </p:txBody>
@@ -3200,7 +3200,7 @@
                 </a:solidFill>
                 <a:latin typeface="Georgia"/>
               </a:rPr>
-              <a:t>London office decisions need a trusted starting point</a:t>
+              <a:t>What changed — and what does it mean for a lease?</a:t>
             </a:r>
           </a:p>
         </p:txBody>
@@ -3213,8 +3213,8 @@
         </p:nvSpPr>
         <p:spPr>
           <a:xfrm>
-            <a:off x="640080" y="2057400"/>
-            <a:ext cx="5943600" cy="1280160"/>
+            <a:off x="731520" y="2057400"/>
+            <a:ext cx="5669280" cy="1371600"/>
           </a:xfrm>
           <a:prstGeom prst="rect">
             <a:avLst/>
@@ -3235,8 +3235,8 @@
                 </a:solidFill>
                 <a:latin typeface="Georgia"/>
               </a:rPr>
-              <a:t>The question is rarely
-just a number.</a:t>
+              <a:t>Discover reports.
+Compare the evidence.</a:t>
             </a:r>
           </a:p>
         </p:txBody>
@@ -3249,8 +3249,8 @@
         </p:nvSpPr>
         <p:spPr>
           <a:xfrm>
-            <a:off x="658368" y="3749039"/>
-            <a:ext cx="5303520" cy="914400"/>
+            <a:off x="749808" y="3931920"/>
+            <a:ext cx="5486400" cy="1188720"/>
           </a:xfrm>
           <a:prstGeom prst="rect">
             <a:avLst/>
@@ -3265,13 +3265,13 @@
           <a:p>
             <a:pPr algn="l"/>
             <a:r>
-              <a:rPr sz="1700" b="0">
+              <a:rPr sz="1800" b="0">
                 <a:solidFill>
                   <a:srgbClr val="708087"/>
                 </a:solidFill>
                 <a:latin typeface="Aptos"/>
               </a:rPr>
-              <a:t>Teams need a current view of rents, vacancy, supply and macro context — with the evidence trail attached.</a:t>
+              <a:t>Bring rents, demand, supply and macro context into one research conversation, with the source trail attached.</a:t>
             </a:r>
           </a:p>
         </p:txBody>
@@ -3285,7 +3285,7 @@
         <p:spPr>
           <a:xfrm>
             <a:off x="7315200" y="2011680"/>
-            <a:ext cx="4160520" cy="2926080"/>
+            <a:ext cx="4114800" cy="3200400"/>
           </a:xfrm>
           <a:prstGeom prst="rect">
             <a:avLst/>
@@ -3330,7 +3330,7 @@
         <p:spPr>
           <a:xfrm>
             <a:off x="7516368" y="2194560"/>
-            <a:ext cx="3758183" cy="274320"/>
+            <a:ext cx="3712463" cy="274320"/>
           </a:xfrm>
           <a:prstGeom prst="rect">
             <a:avLst/>
@@ -3351,7 +3351,7 @@
                 </a:solidFill>
                 <a:latin typeface="Aptos"/>
               </a:rPr>
-              <a:t>PRODUCT</a:t>
+              <a:t>BUSINESS QUESTION</a:t>
             </a:r>
           </a:p>
         </p:txBody>
@@ -3365,7 +3365,7 @@
         <p:spPr>
           <a:xfrm>
             <a:off x="7516368" y="2633472"/>
-            <a:ext cx="3758183" cy="2148840"/>
+            <a:ext cx="3712463" cy="2423160"/>
           </a:xfrm>
           <a:prstGeom prst="rect">
             <a:avLst/>
@@ -3386,7 +3386,7 @@
                 </a:solidFill>
                 <a:latin typeface="Aptos"/>
               </a:rPr>
-              <a:t>A local-first monitor that turns a plain-language question into a concise answer, metrics, citations and a run trace.</a:t>
+              <a:t>Where is occupier demand strengthening, and could constrained quality supply change the timing or terms of our next leasing decision?</a:t>
             </a:r>
           </a:p>
         </p:txBody>
@@ -3447,7 +3447,7 @@
                 </a:solidFill>
                 <a:latin typeface="Aptos"/>
               </a:rPr>
-              <a:t>LONDON MARKET MONITOR  /  THE PRODUCT  ·  DEMO DATA</a:t>
+              <a:t>LONDON MARKET MONITOR  /  WORKFLOW  ·  LIVE RESEARCH</a:t>
             </a:r>
           </a:p>
         </p:txBody>
@@ -3517,7 +3517,7 @@
                 </a:solidFill>
                 <a:latin typeface="Georgia"/>
               </a:rPr>
-              <a:t>One path from question to grounded answer</a:t>
+              <a:t>One bounded research loop</a:t>
             </a:r>
           </a:p>
         </p:txBody>
@@ -3530,8 +3530,8 @@
         </p:nvSpPr>
         <p:spPr>
           <a:xfrm>
-            <a:off x="731520" y="2057400"/>
-            <a:ext cx="1828800" cy="2286000"/>
+            <a:off x="731520" y="2103120"/>
+            <a:ext cx="1828800" cy="2743200"/>
           </a:xfrm>
           <a:prstGeom prst="rect">
             <a:avLst/>
@@ -3575,7 +3575,7 @@
         </p:nvSpPr>
         <p:spPr>
           <a:xfrm>
-            <a:off x="932688" y="2240280"/>
+            <a:off x="932688" y="2286000"/>
             <a:ext cx="1426464" cy="274320"/>
           </a:xfrm>
           <a:prstGeom prst="rect">
@@ -3597,7 +3597,7 @@
                 </a:solidFill>
                 <a:latin typeface="Aptos"/>
               </a:rPr>
-              <a:t>ASK</a:t>
+              <a:t>DISCOVER</a:t>
             </a:r>
           </a:p>
         </p:txBody>
@@ -3610,8 +3610,8 @@
         </p:nvSpPr>
         <p:spPr>
           <a:xfrm>
-            <a:off x="932688" y="2679192"/>
-            <a:ext cx="1426464" cy="1508760"/>
+            <a:off x="932688" y="2724912"/>
+            <a:ext cx="1426464" cy="1965960"/>
           </a:xfrm>
           <a:prstGeom prst="rect">
             <a:avLst/>
@@ -3632,7 +3632,7 @@
                 </a:solidFill>
                 <a:latin typeface="Aptos"/>
               </a:rPr>
-              <a:t>Plain-language question</a:t>
+              <a:t>Find broker, official and developer reports</a:t>
             </a:r>
           </a:p>
         </p:txBody>
@@ -3645,8 +3645,8 @@
         </p:nvSpPr>
         <p:spPr>
           <a:xfrm>
-            <a:off x="3063240" y="2057400"/>
-            <a:ext cx="1828800" cy="2286000"/>
+            <a:off x="3063240" y="2103120"/>
+            <a:ext cx="1828800" cy="2743200"/>
           </a:xfrm>
           <a:prstGeom prst="rect">
             <a:avLst/>
@@ -3690,7 +3690,7 @@
         </p:nvSpPr>
         <p:spPr>
           <a:xfrm>
-            <a:off x="3264408" y="2240280"/>
+            <a:off x="3264408" y="2286000"/>
             <a:ext cx="1426464" cy="274320"/>
           </a:xfrm>
           <a:prstGeom prst="rect">
@@ -3712,7 +3712,7 @@
                 </a:solidFill>
                 <a:latin typeface="Aptos"/>
               </a:rPr>
-              <a:t>ROUTE</a:t>
+              <a:t>READ</a:t>
             </a:r>
           </a:p>
         </p:txBody>
@@ -3725,8 +3725,8 @@
         </p:nvSpPr>
         <p:spPr>
           <a:xfrm>
-            <a:off x="3264408" y="2679192"/>
-            <a:ext cx="1426464" cy="1508760"/>
+            <a:off x="3264408" y="2724912"/>
+            <a:ext cx="1426464" cy="1965960"/>
           </a:xfrm>
           <a:prstGeom prst="rect">
             <a:avLst/>
@@ -3747,7 +3747,7 @@
                 </a:solidFill>
                 <a:latin typeface="Aptos"/>
               </a:rPr>
-              <a:t>Skills + typed queries</a:t>
+              <a:t>Extract public pages and text PDFs</a:t>
             </a:r>
           </a:p>
         </p:txBody>
@@ -3760,8 +3760,8 @@
         </p:nvSpPr>
         <p:spPr>
           <a:xfrm>
-            <a:off x="5394960" y="2057400"/>
-            <a:ext cx="1828800" cy="2286000"/>
+            <a:off x="5394960" y="2103120"/>
+            <a:ext cx="1828800" cy="2743200"/>
           </a:xfrm>
           <a:prstGeom prst="rect">
             <a:avLst/>
@@ -3805,7 +3805,7 @@
         </p:nvSpPr>
         <p:spPr>
           <a:xfrm>
-            <a:off x="5596128" y="2240280"/>
+            <a:off x="5596128" y="2286000"/>
             <a:ext cx="1426464" cy="274320"/>
           </a:xfrm>
           <a:prstGeom prst="rect">
@@ -3827,7 +3827,7 @@
                 </a:solidFill>
                 <a:latin typeface="Aptos"/>
               </a:rPr>
-              <a:t>EVIDENCE</a:t>
+              <a:t>COMPARE</a:t>
             </a:r>
           </a:p>
         </p:txBody>
@@ -3840,8 +3840,8 @@
         </p:nvSpPr>
         <p:spPr>
           <a:xfrm>
-            <a:off x="5596128" y="2679192"/>
-            <a:ext cx="1426464" cy="1508760"/>
+            <a:off x="5596128" y="2724912"/>
+            <a:ext cx="1426464" cy="1965960"/>
           </a:xfrm>
           <a:prstGeom prst="rect">
             <a:avLst/>
@@ -3862,7 +3862,7 @@
                 </a:solidFill>
                 <a:latin typeface="Aptos"/>
               </a:rPr>
-              <a:t>SQLite + lexical retrieval</a:t>
+              <a:t>Retrieve passages; align definitions and periods</a:t>
             </a:r>
           </a:p>
         </p:txBody>
@@ -3875,8 +3875,8 @@
         </p:nvSpPr>
         <p:spPr>
           <a:xfrm>
-            <a:off x="7726679" y="2057400"/>
-            <a:ext cx="1828800" cy="2286000"/>
+            <a:off x="7726679" y="2103120"/>
+            <a:ext cx="1828800" cy="2743200"/>
           </a:xfrm>
           <a:prstGeom prst="rect">
             <a:avLst/>
@@ -3920,7 +3920,7 @@
         </p:nvSpPr>
         <p:spPr>
           <a:xfrm>
-            <a:off x="7927848" y="2240280"/>
+            <a:off x="7927848" y="2286000"/>
             <a:ext cx="1426464" cy="274320"/>
           </a:xfrm>
           <a:prstGeom prst="rect">
@@ -3942,7 +3942,7 @@
                 </a:solidFill>
                 <a:latin typeface="Aptos"/>
               </a:rPr>
-              <a:t>VERIFY</a:t>
+              <a:t>EXPLAIN</a:t>
             </a:r>
           </a:p>
         </p:txBody>
@@ -3955,8 +3955,8 @@
         </p:nvSpPr>
         <p:spPr>
           <a:xfrm>
-            <a:off x="7927848" y="2679192"/>
-            <a:ext cx="1426464" cy="1508760"/>
+            <a:off x="7927848" y="2724912"/>
+            <a:ext cx="1426464" cy="1965960"/>
           </a:xfrm>
           <a:prstGeom prst="rect">
             <a:avLst/>
@@ -3977,7 +3977,7 @@
                 </a:solidFill>
                 <a:latin typeface="Aptos"/>
               </a:rPr>
-              <a:t>Source IDs + citations</a:t>
+              <a:t>Separate reported facts from implications</a:t>
             </a:r>
           </a:p>
         </p:txBody>
@@ -3990,8 +3990,8 @@
         </p:nvSpPr>
         <p:spPr>
           <a:xfrm>
-            <a:off x="10058400" y="2057400"/>
-            <a:ext cx="1828800" cy="2286000"/>
+            <a:off x="10058400" y="2103120"/>
+            <a:ext cx="1828800" cy="2743200"/>
           </a:xfrm>
           <a:prstGeom prst="rect">
             <a:avLst/>
@@ -4035,7 +4035,7 @@
         </p:nvSpPr>
         <p:spPr>
           <a:xfrm>
-            <a:off x="10259568" y="2240280"/>
+            <a:off x="10259568" y="2286000"/>
             <a:ext cx="1426464" cy="274320"/>
           </a:xfrm>
           <a:prstGeom prst="rect">
@@ -4057,7 +4057,7 @@
                 </a:solidFill>
                 <a:latin typeface="Aptos"/>
               </a:rPr>
-              <a:t>ANSWER</a:t>
+              <a:t>CHECK</a:t>
             </a:r>
           </a:p>
         </p:txBody>
@@ -4070,8 +4070,8 @@
         </p:nvSpPr>
         <p:spPr>
           <a:xfrm>
-            <a:off x="10259568" y="2679192"/>
-            <a:ext cx="1426464" cy="1508760"/>
+            <a:off x="10259568" y="2724912"/>
+            <a:ext cx="1426464" cy="1965960"/>
           </a:xfrm>
           <a:prstGeom prst="rect">
             <a:avLst/>
@@ -4092,7 +4092,7 @@
                 </a:solidFill>
                 <a:latin typeface="Aptos"/>
               </a:rPr>
-              <a:t>UI, API or CLI</a:t>
+              <a:t>Open citations and inspect missing evidence</a:t>
             </a:r>
           </a:p>
         </p:txBody>
@@ -4105,7 +4105,7 @@
         </p:nvSpPr>
         <p:spPr>
           <a:xfrm>
-            <a:off x="777240" y="5029200"/>
+            <a:off x="777240" y="5349240"/>
             <a:ext cx="10515600" cy="594360"/>
           </a:xfrm>
           <a:prstGeom prst="rect">
@@ -4127,7 +4127,7 @@
                 </a:solidFill>
                 <a:latin typeface="Aptos"/>
               </a:rPr>
-              <a:t>Question  →  intent and skill routing  →  market data + evidence  →  grounded answer with citations</a:t>
+              <a:t>z.ai chooses tools • Firecrawl reads sources • FastEmbed + Qdrant retrieves • SQLite preserves observations</a:t>
             </a:r>
           </a:p>
         </p:txBody>
@@ -4188,7 +4188,7 @@
                 </a:solidFill>
                 <a:latin typeface="Aptos"/>
               </a:rPr>
-              <a:t>LONDON MARKET MONITOR  /  EXAMPLE WORKFLOW  ·  DEMO DATA</a:t>
+              <a:t>LONDON MARKET MONITOR  /  LIVE CHECK  ·  LIVE RESEARCH</a:t>
             </a:r>
           </a:p>
         </p:txBody>
@@ -4258,7 +4258,7 @@
                 </a:solidFill>
                 <a:latin typeface="Georgia"/>
               </a:rPr>
-              <a:t>“What is happening to prime rents in the City?”</a:t>
+              <a:t>A recorded run, with its limits visible</a:t>
             </a:r>
           </a:p>
         </p:txBody>
@@ -4272,7 +4272,7 @@
         <p:spPr>
           <a:xfrm>
             <a:off x="731520" y="1920240"/>
-            <a:ext cx="3291840" cy="3246120"/>
+            <a:ext cx="6400800" cy="3566160"/>
           </a:xfrm>
           <a:prstGeom prst="rect">
             <a:avLst/>
@@ -4317,7 +4317,7 @@
         <p:spPr>
           <a:xfrm>
             <a:off x="932688" y="2103120"/>
-            <a:ext cx="2889504" cy="274320"/>
+            <a:ext cx="5998464" cy="274320"/>
           </a:xfrm>
           <a:prstGeom prst="rect">
             <a:avLst/>
@@ -4338,7 +4338,7 @@
                 </a:solidFill>
                 <a:latin typeface="Aptos"/>
               </a:rPr>
-              <a:t>1  RETRIEVE</a:t>
+              <a:t>ACTUAL MODEL ANSWER</a:t>
             </a:r>
           </a:p>
         </p:txBody>
@@ -4352,7 +4352,7 @@
         <p:spPr>
           <a:xfrm>
             <a:off x="932688" y="2542032"/>
-            <a:ext cx="2889504" cy="2468879"/>
+            <a:ext cx="5998464" cy="2788920"/>
           </a:xfrm>
           <a:prstGeom prst="rect">
             <a:avLst/>
@@ -4373,11 +4373,8 @@
                 </a:solidFill>
                 <a:latin typeface="Aptos"/>
               </a:rPr>
-              <a:t>Metric query
-City · prime_rent
-Latest stored period
-Evidence search
-City + current</a:t>
+              <a:t>Per the stored JLL 'Central London Office Market Dynamics Q2 2026' report, take-up reached 2.6 million sq.ft. in Q2 2026, up 15% quarter-on-quarter and above the 10-year average, led by a strong West End performance.
+Implication: with take-up above its 10-year average while supply shrinks and the construction pipeline thins, occupiers with defined requirements may benefit from starting searches and committing earlier, as choice and negotiating leverage could diminish.</a:t>
             </a:r>
           </a:p>
         </p:txBody>
@@ -4390,8 +4387,8 @@
         </p:nvSpPr>
         <p:spPr>
           <a:xfrm>
-            <a:off x="4434840" y="1920240"/>
-            <a:ext cx="3291840" cy="3246120"/>
+            <a:off x="7498079" y="1920240"/>
+            <a:ext cx="3931920" cy="3566160"/>
           </a:xfrm>
           <a:prstGeom prst="rect">
             <a:avLst/>
@@ -4435,8 +4432,8 @@
         </p:nvSpPr>
         <p:spPr>
           <a:xfrm>
-            <a:off x="4636007" y="2103120"/>
-            <a:ext cx="2889504" cy="274320"/>
+            <a:off x="7699248" y="2103120"/>
+            <a:ext cx="3529584" cy="274320"/>
           </a:xfrm>
           <a:prstGeom prst="rect">
             <a:avLst/>
@@ -4457,7 +4454,7 @@
                 </a:solidFill>
                 <a:latin typeface="Aptos"/>
               </a:rPr>
-              <a:t>2  COMBINE</a:t>
+              <a:t>EVIDENCE TRAIL</a:t>
             </a:r>
           </a:p>
         </p:txBody>
@@ -4470,8 +4467,8 @@
         </p:nvSpPr>
         <p:spPr>
           <a:xfrm>
-            <a:off x="4636007" y="2542032"/>
-            <a:ext cx="2889504" cy="2468879"/>
+            <a:off x="7699248" y="2542032"/>
+            <a:ext cx="3529584" cy="2788920"/>
           </a:xfrm>
           <a:prstGeom prst="rect">
             <a:avLst/>
@@ -4492,67 +4489,25 @@
                 </a:solidFill>
                 <a:latin typeface="Aptos"/>
               </a:rPr>
-              <a:t>City prime rent: 85 GBP/sq ft/year (2026-Q1)
-Evidence snapshot: stored demo data, not a live feed.</a:t>
-            </a:r>
-          </a:p>
-        </p:txBody>
-      </p:sp>
-      <p:sp>
-        <p:nvSpPr>
-          <p:cNvPr id="11" name="Rectangle 10"/>
-          <p:cNvSpPr/>
-          <p:nvPr/>
-        </p:nvSpPr>
-        <p:spPr>
-          <a:xfrm>
-            <a:off x="8138160" y="1920240"/>
-            <a:ext cx="3291840" cy="3246120"/>
-          </a:xfrm>
-          <a:prstGeom prst="rect">
-            <a:avLst/>
-          </a:prstGeom>
-          <a:solidFill>
-            <a:srgbClr val="FFFDF8"/>
-          </a:solidFill>
-          <a:ln>
-            <a:solidFill>
-              <a:srgbClr val="D7D5CB"/>
-            </a:solidFill>
-          </a:ln>
-        </p:spPr>
-        <p:style>
-          <a:lnRef idx="1">
-            <a:schemeClr val="accent1"/>
-          </a:lnRef>
-          <a:fillRef idx="3">
-            <a:schemeClr val="accent1"/>
-          </a:fillRef>
-          <a:effectRef idx="2">
-            <a:schemeClr val="accent1"/>
-          </a:effectRef>
-          <a:fontRef idx="minor">
-            <a:schemeClr val="lt1"/>
-          </a:fontRef>
-        </p:style>
-        <p:txBody>
-          <a:bodyPr rtlCol="0" anchor="ctr"/>
-          <a:lstStyle/>
-          <a:p>
-            <a:pPr algn="ctr"/>
-          </a:p>
-        </p:txBody>
-      </p:sp>
-      <p:sp>
-        <p:nvSpPr>
-          <p:cNvPr id="12" name="TextBox 11"/>
+              <a:t>1 cited source(s) · incomplete
+search_web
+query_market_metrics
+search_market_evidence
+Directly ingested public report. Local vector check. Firecrawl was not used in this run.</a:t>
+            </a:r>
+          </a:p>
+        </p:txBody>
+      </p:sp>
+      <p:sp>
+        <p:nvSpPr>
+          <p:cNvPr id="11" name="TextBox 10"/>
           <p:cNvSpPr txBox="1"/>
           <p:nvPr/>
         </p:nvSpPr>
         <p:spPr>
           <a:xfrm>
-            <a:off x="8339328" y="2103120"/>
-            <a:ext cx="2889504" cy="274320"/>
+            <a:off x="777240" y="5897880"/>
+            <a:ext cx="10607040" cy="457200"/>
           </a:xfrm>
           <a:prstGeom prst="rect">
             <a:avLst/>
@@ -4567,50 +4522,13 @@
           <a:p>
             <a:pPr algn="l"/>
             <a:r>
-              <a:rPr sz="900" b="1">
-                <a:solidFill>
-                  <a:srgbClr val="1B8077"/>
+              <a:rPr sz="1000" b="0">
+                <a:solidFill>
+                  <a:srgbClr val="708087"/>
                 </a:solidFill>
                 <a:latin typeface="Aptos"/>
               </a:rPr>
-              <a:t>3  RETURN</a:t>
-            </a:r>
-          </a:p>
-        </p:txBody>
-      </p:sp>
-      <p:sp>
-        <p:nvSpPr>
-          <p:cNvPr id="13" name="TextBox 12"/>
-          <p:cNvSpPr txBox="1"/>
-          <p:nvPr/>
-        </p:nvSpPr>
-        <p:spPr>
-          <a:xfrm>
-            <a:off x="8339328" y="2542032"/>
-            <a:ext cx="2889504" cy="2468879"/>
-          </a:xfrm>
-          <a:prstGeom prst="rect">
-            <a:avLst/>
-          </a:prstGeom>
-          <a:noFill/>
-        </p:spPr>
-        <p:txBody>
-          <a:bodyPr wrap="square" lIns="18288" rIns="18288" anchor="t">
-            <a:spAutoFit/>
-          </a:bodyPr>
-          <a:lstStyle/>
-          <a:p>
-            <a:pPr algn="l"/>
-            <a:r>
-              <a:rPr sz="1500" b="0">
-                <a:solidFill>
-                  <a:srgbClr val="102331"/>
-                </a:solidFill>
-                <a:latin typeface="Aptos"/>
-              </a:rPr>
-              <a:t>Answer with [1] citations
-Publisher + date + URL
-Trace: metrics · evidence · verify</a:t>
+              <a:t>Source: https://www.jll.com/en-uk/insights/market-dynamics/central-london-office</a:t>
             </a:r>
           </a:p>
         </p:txBody>
@@ -4671,7 +4589,7 @@
                 </a:solidFill>
                 <a:latin typeface="Aptos"/>
               </a:rPr>
-              <a:t>LONDON MARKET MONITOR  /  TRUST  ·  DEMO DATA</a:t>
+              <a:t>LONDON MARKET MONITOR  /  CHANGE BRIEFING  ·  LIVE RESEARCH</a:t>
             </a:r>
           </a:p>
         </p:txBody>
@@ -4741,7 +4659,7 @@
                 </a:solidFill>
                 <a:latin typeface="Georgia"/>
               </a:rPr>
-              <a:t>Reliability is part of the answer</a:t>
+              <a:t>Separate a changed market from a changed source</a:t>
             </a:r>
           </a:p>
         </p:txBody>
@@ -4755,7 +4673,7 @@
         <p:spPr>
           <a:xfrm>
             <a:off x="731520" y="1965960"/>
-            <a:ext cx="4892040" cy="1417320"/>
+            <a:ext cx="4892040" cy="1645920"/>
           </a:xfrm>
           <a:prstGeom prst="rect">
             <a:avLst/>
@@ -4821,7 +4739,7 @@
                 </a:solidFill>
                 <a:latin typeface="Aptos"/>
               </a:rPr>
-              <a:t>TYPED</a:t>
+              <a:t>NEW REPORT</a:t>
             </a:r>
           </a:p>
         </p:txBody>
@@ -4835,7 +4753,7 @@
         <p:spPr>
           <a:xfrm>
             <a:off x="932688" y="2587752"/>
-            <a:ext cx="4489703" cy="640080"/>
+            <a:ext cx="4489703" cy="868680"/>
           </a:xfrm>
           <a:prstGeom prst="rect">
             <a:avLst/>
@@ -4856,7 +4774,7 @@
                 </a:solidFill>
                 <a:latin typeface="Aptos"/>
               </a:rPr>
-              <a:t>Pydantic contracts at every boundary</a:t>
+              <a:t>Discoveries establish coverage; they do not alone prove market movement.</a:t>
             </a:r>
           </a:p>
         </p:txBody>
@@ -4870,7 +4788,7 @@
         <p:spPr>
           <a:xfrm>
             <a:off x="6263640" y="1965960"/>
-            <a:ext cx="4892040" cy="1417320"/>
+            <a:ext cx="4892040" cy="1645920"/>
           </a:xfrm>
           <a:prstGeom prst="rect">
             <a:avLst/>
@@ -4936,7 +4854,7 @@
                 </a:solidFill>
                 <a:latin typeface="Aptos"/>
               </a:rPr>
-              <a:t>BOUNDED</a:t>
+              <a:t>REVISED CONTENT</a:t>
             </a:r>
           </a:p>
         </p:txBody>
@@ -4950,7 +4868,7 @@
         <p:spPr>
           <a:xfrm>
             <a:off x="6464807" y="2587752"/>
-            <a:ext cx="4489703" cy="640080"/>
+            <a:ext cx="4489703" cy="868680"/>
           </a:xfrm>
           <a:prstGeom prst="rect">
             <a:avLst/>
@@ -4971,7 +4889,7 @@
                 </a:solidFill>
                 <a:latin typeface="Aptos"/>
               </a:rPr>
-              <a:t>Parameterized, limited queries</a:t>
+              <a:t>Same URL, different checksum: retain both versions and source IDs.</a:t>
             </a:r>
           </a:p>
         </p:txBody>
@@ -4984,8 +4902,8 @@
         </p:nvSpPr>
         <p:spPr>
           <a:xfrm>
-            <a:off x="731520" y="3657600"/>
-            <a:ext cx="4892040" cy="1417320"/>
+            <a:off x="731520" y="3749039"/>
+            <a:ext cx="4892040" cy="1645920"/>
           </a:xfrm>
           <a:prstGeom prst="rect">
             <a:avLst/>
@@ -5029,7 +4947,7 @@
         </p:nvSpPr>
         <p:spPr>
           <a:xfrm>
-            <a:off x="932688" y="3840480"/>
+            <a:off x="932688" y="3931920"/>
             <a:ext cx="4489703" cy="274320"/>
           </a:xfrm>
           <a:prstGeom prst="rect">
@@ -5051,7 +4969,7 @@
                 </a:solidFill>
                 <a:latin typeface="Aptos"/>
               </a:rPr>
-              <a:t>GROUNDED</a:t>
+              <a:t>COMPARABLE CHANGE</a:t>
             </a:r>
           </a:p>
         </p:txBody>
@@ -5064,8 +4982,8 @@
         </p:nvSpPr>
         <p:spPr>
           <a:xfrm>
-            <a:off x="932688" y="4279392"/>
-            <a:ext cx="4489703" cy="640080"/>
+            <a:off x="932688" y="4370831"/>
+            <a:ext cx="4489703" cy="868680"/>
           </a:xfrm>
           <a:prstGeom prst="rect">
             <a:avLst/>
@@ -5086,7 +5004,7 @@
                 </a:solidFill>
                 <a:latin typeface="Aptos"/>
               </a:rPr>
-              <a:t>Unknown claims are rejected</a:t>
+              <a:t>Match units, periods and definitions; calculate differences in code.</a:t>
             </a:r>
           </a:p>
         </p:txBody>
@@ -5099,8 +5017,8 @@
         </p:nvSpPr>
         <p:spPr>
           <a:xfrm>
-            <a:off x="6263640" y="3657600"/>
-            <a:ext cx="4892040" cy="1417320"/>
+            <a:off x="6263640" y="3749039"/>
+            <a:ext cx="4892040" cy="1645920"/>
           </a:xfrm>
           <a:prstGeom prst="rect">
             <a:avLst/>
@@ -5144,7 +5062,7 @@
         </p:nvSpPr>
         <p:spPr>
           <a:xfrm>
-            <a:off x="6464807" y="3840480"/>
+            <a:off x="6464807" y="3931920"/>
             <a:ext cx="4489703" cy="274320"/>
           </a:xfrm>
           <a:prstGeom prst="rect">
@@ -5166,7 +5084,7 @@
                 </a:solidFill>
                 <a:latin typeface="Aptos"/>
               </a:rPr>
-              <a:t>TRANSPARENT</a:t>
+              <a:t>BUSINESS IMPLICATION</a:t>
             </a:r>
           </a:p>
         </p:txBody>
@@ -5179,8 +5097,8 @@
         </p:nvSpPr>
         <p:spPr>
           <a:xfrm>
-            <a:off x="6464807" y="4279392"/>
-            <a:ext cx="4489703" cy="640080"/>
+            <a:off x="6464807" y="4370831"/>
+            <a:ext cx="4489703" cy="868680"/>
           </a:xfrm>
           <a:prstGeom prst="rect">
             <a:avLst/>
@@ -5201,7 +5119,7 @@
                 </a:solidFill>
                 <a:latin typeface="Aptos"/>
               </a:rPr>
-              <a:t>Warnings, trace and demo label</a:t>
+              <a:t>Qualify timing and supply risks; expose disagreement and collection gaps.</a:t>
             </a:r>
           </a:p>
         </p:txBody>
@@ -5262,7 +5180,7 @@
                 </a:solidFill>
                 <a:latin typeface="Aptos"/>
               </a:rPr>
-              <a:t>LONDON MARKET MONITOR  /  NEXT  ·  DEMO DATA</a:t>
+              <a:t>LONDON MARKET MONITOR  /  READINESS  ·  LIVE RESEARCH</a:t>
             </a:r>
           </a:p>
         </p:txBody>
@@ -5332,7 +5250,7 @@
                 </a:solidFill>
                 <a:latin typeface="Georgia"/>
               </a:rPr>
-              <a:t>A focused PoC with a clear production path</a:t>
+              <a:t>Implemented; full live readiness still needs verification</a:t>
             </a:r>
           </a:p>
         </p:txBody>
@@ -5346,7 +5264,7 @@
         <p:spPr>
           <a:xfrm>
             <a:off x="731520" y="1920240"/>
-            <a:ext cx="3337560" cy="3200400"/>
+            <a:ext cx="3337560" cy="3474720"/>
           </a:xfrm>
           <a:prstGeom prst="rect">
             <a:avLst/>
@@ -5412,7 +5330,7 @@
                 </a:solidFill>
                 <a:latin typeface="Aptos"/>
               </a:rPr>
-              <a:t>TODAY · POC</a:t>
+              <a:t>DELIVERED</a:t>
             </a:r>
           </a:p>
         </p:txBody>
@@ -5426,7 +5344,7 @@
         <p:spPr>
           <a:xfrm>
             <a:off x="932688" y="2542032"/>
-            <a:ext cx="2935224" cy="2423160"/>
+            <a:ext cx="2935224" cy="2697479"/>
           </a:xfrm>
           <a:prstGeom prst="rect">
             <a:avLst/>
@@ -5447,11 +5365,11 @@
                 </a:solidFill>
                 <a:latin typeface="Aptos"/>
               </a:rPr>
-              <a:t>Offline by default
-Synthetic seed data
-Hashed lexical vectors
-One local worker
-Text ingestion</a:t>
+              <a:t>Tool-driven chat
+Semantic evidence
+Manual refresh + briefing
+Source versions + citations
+Explicit demo isolation</a:t>
             </a:r>
           </a:p>
         </p:txBody>
@@ -5465,7 +5383,7 @@
         <p:spPr>
           <a:xfrm>
             <a:off x="4434840" y="1920240"/>
-            <a:ext cx="3337560" cy="3200400"/>
+            <a:ext cx="3337560" cy="3474720"/>
           </a:xfrm>
           <a:prstGeom prst="rect">
             <a:avLst/>
@@ -5531,7 +5449,7 @@
                 </a:solidFill>
                 <a:latin typeface="Aptos"/>
               </a:rPr>
-              <a:t>NEXT · HARDEN</a:t>
+              <a:t>VERIFIED</a:t>
             </a:r>
           </a:p>
         </p:txBody>
@@ -5545,7 +5463,7 @@
         <p:spPr>
           <a:xfrm>
             <a:off x="4636007" y="2542032"/>
-            <a:ext cx="2935224" cy="2423160"/>
+            <a:ext cx="2935224" cy="2697479"/>
           </a:xfrm>
           <a:prstGeom prst="rect">
             <a:avLst/>
@@ -5566,11 +5484,11 @@
                 </a:solidFill>
                 <a:latin typeface="Aptos"/>
               </a:rPr>
-              <a:t>Curated connectors
-Freshness SLAs
-Stronger embeddings
-Server storage
-Access control</a:t>
+              <a:t>Automated grounding tests
+Deterministic evaluation
+Real model tool calls
+Real semantic retrieval
+Compose configuration</a:t>
             </a:r>
           </a:p>
         </p:txBody>
@@ -5584,7 +5502,7 @@
         <p:spPr>
           <a:xfrm>
             <a:off x="8138160" y="1920240"/>
-            <a:ext cx="3337560" cy="3200400"/>
+            <a:ext cx="3337560" cy="3474720"/>
           </a:xfrm>
           <a:prstGeom prst="rect">
             <a:avLst/>
@@ -5650,7 +5568,7 @@
                 </a:solidFill>
                 <a:latin typeface="Aptos"/>
               </a:rPr>
-              <a:t>MEASURE · PROVE</a:t>
+              <a:t>REMAINING BLOCKER</a:t>
             </a:r>
           </a:p>
         </p:txBody>
@@ -5664,7 +5582,7 @@
         <p:spPr>
           <a:xfrm>
             <a:off x="8339328" y="2542032"/>
-            <a:ext cx="2935224" cy="2423160"/>
+            <a:ext cx="2935224" cy="2697479"/>
           </a:xfrm>
           <a:prstGeom prst="rect">
             <a:avLst/>
@@ -5685,11 +5603,8 @@
                 </a:solidFill>
                 <a:latin typeface="Aptos"/>
               </a:rPr>
-              <a:t>Citation coverage
-Retrieval relevance
-Latency by route
-Provider fallback
-User feedback</a:t>
+              <a:t>Free host disk capacity and restore Docker health.
+Then verify Firecrawl search + scrape, full Compose startup and persistence.</a:t>
             </a:r>
           </a:p>
         </p:txBody>

</xml_diff>

<commit_message>
feat: build grounded London commercial real estate monitoring workflow
</commit_message>
<xml_diff>
--- a/deliverables/london-office-market-agent.pptx
+++ b/deliverables/london-office-market-agent.pptx
@@ -3130,7 +3130,7 @@
                 </a:solidFill>
                 <a:latin typeface="Aptos"/>
               </a:rPr>
-              <a:t>LONDON MARKET MONITOR  /  THE DECISION  ·  LIVE RESEARCH</a:t>
+              <a:t>LONDON MARKET MONITOR  /  THE PROBLEM  ·  MARKET INTELLIGENCE</a:t>
             </a:r>
           </a:p>
         </p:txBody>
@@ -3200,7 +3200,7 @@
                 </a:solidFill>
                 <a:latin typeface="Georgia"/>
               </a:rPr>
-              <a:t>What changed — and what does it mean for a lease?</a:t>
+              <a:t>Too much reading. Too little time to interpret.</a:t>
             </a:r>
           </a:p>
         </p:txBody>
@@ -3213,8 +3213,8 @@
         </p:nvSpPr>
         <p:spPr>
           <a:xfrm>
-            <a:off x="731520" y="2057400"/>
-            <a:ext cx="5669280" cy="1371600"/>
+            <a:off x="731520" y="2011680"/>
+            <a:ext cx="5577840" cy="1554480"/>
           </a:xfrm>
           <a:prstGeom prst="rect">
             <a:avLst/>
@@ -3229,14 +3229,14 @@
           <a:p>
             <a:pPr algn="l"/>
             <a:r>
-              <a:rPr sz="3200" b="1">
+              <a:rPr sz="3100" b="1">
                 <a:solidFill>
                   <a:srgbClr val="102331"/>
                 </a:solidFill>
                 <a:latin typeface="Georgia"/>
               </a:rPr>
-              <a:t>Discover reports.
-Compare the evidence.</a:t>
+              <a:t>Reports, headlines, macro data.
+One decision to prepare for.</a:t>
             </a:r>
           </a:p>
         </p:txBody>
@@ -3249,8 +3249,8 @@
         </p:nvSpPr>
         <p:spPr>
           <a:xfrm>
-            <a:off x="749808" y="3931920"/>
-            <a:ext cx="5486400" cy="1188720"/>
+            <a:off x="749808" y="3977639"/>
+            <a:ext cx="5394960" cy="1188720"/>
           </a:xfrm>
           <a:prstGeom prst="rect">
             <a:avLst/>
@@ -3271,7 +3271,7 @@
                 </a:solidFill>
                 <a:latin typeface="Aptos"/>
               </a:rPr>
-              <a:t>Bring rents, demand, supply and macro context into one research conversation, with the source trail attached.</a:t>
+              <a:t>Teams repeatedly find reports, reconcile periods and rebuild the same evidence trail. The important change can be buried in a familiar market summary.</a:t>
             </a:r>
           </a:p>
         </p:txBody>
@@ -3284,8 +3284,8 @@
         </p:nvSpPr>
         <p:spPr>
           <a:xfrm>
-            <a:off x="7315200" y="2011680"/>
-            <a:ext cx="4114800" cy="3200400"/>
+            <a:off x="6858000" y="2011680"/>
+            <a:ext cx="4572000" cy="3383280"/>
           </a:xfrm>
           <a:prstGeom prst="rect">
             <a:avLst/>
@@ -3329,8 +3329,8 @@
         </p:nvSpPr>
         <p:spPr>
           <a:xfrm>
-            <a:off x="7516368" y="2194560"/>
-            <a:ext cx="3712463" cy="274320"/>
+            <a:off x="7059168" y="2194560"/>
+            <a:ext cx="4169663" cy="274320"/>
           </a:xfrm>
           <a:prstGeom prst="rect">
             <a:avLst/>
@@ -3351,7 +3351,7 @@
                 </a:solidFill>
                 <a:latin typeface="Aptos"/>
               </a:rPr>
-              <a:t>BUSINESS QUESTION</a:t>
+              <a:t>THE BUSINESS OUTCOME</a:t>
             </a:r>
           </a:p>
         </p:txBody>
@@ -3364,8 +3364,8 @@
         </p:nvSpPr>
         <p:spPr>
           <a:xfrm>
-            <a:off x="7516368" y="2633472"/>
-            <a:ext cx="3712463" cy="2423160"/>
+            <a:off x="7059168" y="2633472"/>
+            <a:ext cx="4169663" cy="2606040"/>
           </a:xfrm>
           <a:prstGeom prst="rect">
             <a:avLst/>
@@ -3386,7 +3386,8 @@
                 </a:solidFill>
                 <a:latin typeface="Aptos"/>
               </a:rPr>
-              <a:t>Where is occupier demand strengthening, and could constrained quality supply change the timing or terms of our next leasing decision?</a:t>
+              <a:t>Move from raw information to important changes, plausible drivers and implications worth investigating.
+Bring the evidence into the meeting, with the uncertainty intact.</a:t>
             </a:r>
           </a:p>
         </p:txBody>
@@ -3447,7 +3448,7 @@
                 </a:solidFill>
                 <a:latin typeface="Aptos"/>
               </a:rPr>
-              <a:t>LONDON MARKET MONITOR  /  WORKFLOW  ·  LIVE RESEARCH</a:t>
+              <a:t>LONDON MARKET MONITOR  /  THE WORKFLOW  ·  MARKET INTELLIGENCE</a:t>
             </a:r>
           </a:p>
         </p:txBody>
@@ -3517,7 +3518,7 @@
                 </a:solidFill>
                 <a:latin typeface="Georgia"/>
               </a:rPr>
-              <a:t>One bounded research loop</a:t>
+              <a:t>Ask what changed. Leave ready to discuss it.</a:t>
             </a:r>
           </a:p>
         </p:txBody>
@@ -3530,8 +3531,8 @@
         </p:nvSpPr>
         <p:spPr>
           <a:xfrm>
-            <a:off x="731520" y="2103120"/>
-            <a:ext cx="1828800" cy="2743200"/>
+            <a:off x="731520" y="2011680"/>
+            <a:ext cx="3337560" cy="3291840"/>
           </a:xfrm>
           <a:prstGeom prst="rect">
             <a:avLst/>
@@ -3575,8 +3576,8 @@
         </p:nvSpPr>
         <p:spPr>
           <a:xfrm>
-            <a:off x="932688" y="2286000"/>
-            <a:ext cx="1426464" cy="274320"/>
+            <a:off x="932688" y="2194560"/>
+            <a:ext cx="2935224" cy="274320"/>
           </a:xfrm>
           <a:prstGeom prst="rect">
             <a:avLst/>
@@ -3597,7 +3598,7 @@
                 </a:solidFill>
                 <a:latin typeface="Aptos"/>
               </a:rPr>
-              <a:t>DISCOVER</a:t>
+              <a:t>MONITOR</a:t>
             </a:r>
           </a:p>
         </p:txBody>
@@ -3610,8 +3611,8 @@
         </p:nvSpPr>
         <p:spPr>
           <a:xfrm>
-            <a:off x="932688" y="2724912"/>
-            <a:ext cx="1426464" cy="1965960"/>
+            <a:off x="932688" y="2633472"/>
+            <a:ext cx="2935224" cy="2514600"/>
           </a:xfrm>
           <a:prstGeom prst="rect">
             <a:avLst/>
@@ -3632,7 +3633,8 @@
                 </a:solidFill>
                 <a:latin typeface="Aptos"/>
               </a:rPr>
-              <a:t>Find broker, official and developer reports</a:t>
+              <a:t>What happened since I last checked?
+Material movements, new evidence and changing risks, compared with an explicit baseline.</a:t>
             </a:r>
           </a:p>
         </p:txBody>
@@ -3645,8 +3647,8 @@
         </p:nvSpPr>
         <p:spPr>
           <a:xfrm>
-            <a:off x="3063240" y="2103120"/>
-            <a:ext cx="1828800" cy="2743200"/>
+            <a:off x="4434840" y="2011680"/>
+            <a:ext cx="3337560" cy="3291840"/>
           </a:xfrm>
           <a:prstGeom prst="rect">
             <a:avLst/>
@@ -3690,8 +3692,8 @@
         </p:nvSpPr>
         <p:spPr>
           <a:xfrm>
-            <a:off x="3264408" y="2286000"/>
-            <a:ext cx="1426464" cy="274320"/>
+            <a:off x="4636007" y="2194560"/>
+            <a:ext cx="2935224" cy="274320"/>
           </a:xfrm>
           <a:prstGeom prst="rect">
             <a:avLst/>
@@ -3712,7 +3714,7 @@
                 </a:solidFill>
                 <a:latin typeface="Aptos"/>
               </a:rPr>
-              <a:t>READ</a:t>
+              <a:t>INVESTIGATE</a:t>
             </a:r>
           </a:p>
         </p:txBody>
@@ -3725,8 +3727,8 @@
         </p:nvSpPr>
         <p:spPr>
           <a:xfrm>
-            <a:off x="3264408" y="2724912"/>
-            <a:ext cx="1426464" cy="1965960"/>
+            <a:off x="4636007" y="2633472"/>
+            <a:ext cx="2935224" cy="2514600"/>
           </a:xfrm>
           <a:prstGeom prst="rect">
             <a:avLst/>
@@ -3747,7 +3749,8 @@
                 </a:solidFill>
                 <a:latin typeface="Aptos"/>
               </a:rPr>
-              <a:t>Extract public pages and text PDFs</a:t>
+              <a:t>I heard West End is outperforming City. Is it true?
+Test the claim across rents, vacancy, demand, supply and commentary.</a:t>
             </a:r>
           </a:p>
         </p:txBody>
@@ -3760,8 +3763,8 @@
         </p:nvSpPr>
         <p:spPr>
           <a:xfrm>
-            <a:off x="5394960" y="2103120"/>
-            <a:ext cx="1828800" cy="2743200"/>
+            <a:off x="8138160" y="2011680"/>
+            <a:ext cx="3337560" cy="3291840"/>
           </a:xfrm>
           <a:prstGeom prst="rect">
             <a:avLst/>
@@ -3805,8 +3808,8 @@
         </p:nvSpPr>
         <p:spPr>
           <a:xfrm>
-            <a:off x="5596128" y="2286000"/>
-            <a:ext cx="1426464" cy="274320"/>
+            <a:off x="8339328" y="2194560"/>
+            <a:ext cx="2935224" cy="274320"/>
           </a:xfrm>
           <a:prstGeom prst="rect">
             <a:avLst/>
@@ -3827,7 +3830,7 @@
                 </a:solidFill>
                 <a:latin typeface="Aptos"/>
               </a:rPr>
-              <a:t>COMPARE</a:t>
+              <a:t>PREPARE</a:t>
             </a:r>
           </a:p>
         </p:txBody>
@@ -3840,8 +3843,8 @@
         </p:nvSpPr>
         <p:spPr>
           <a:xfrm>
-            <a:off x="5596128" y="2724912"/>
-            <a:ext cx="1426464" cy="1965960"/>
+            <a:off x="8339328" y="2633472"/>
+            <a:ext cx="2935224" cy="2514600"/>
           </a:xfrm>
           <a:prstGeom prst="rect">
             <a:avLst/>
@@ -3862,66 +3865,22 @@
                 </a:solidFill>
                 <a:latin typeface="Aptos"/>
               </a:rPr>
-              <a:t>Retrieve passages; align definitions and periods</a:t>
-            </a:r>
-          </a:p>
-        </p:txBody>
-      </p:sp>
-      <p:sp>
-        <p:nvSpPr>
-          <p:cNvPr id="14" name="Rectangle 13"/>
-          <p:cNvSpPr/>
-          <p:nvPr/>
-        </p:nvSpPr>
-        <p:spPr>
-          <a:xfrm>
-            <a:off x="7726679" y="2103120"/>
-            <a:ext cx="1828800" cy="2743200"/>
-          </a:xfrm>
-          <a:prstGeom prst="rect">
-            <a:avLst/>
-          </a:prstGeom>
-          <a:solidFill>
-            <a:srgbClr val="193340"/>
-          </a:solidFill>
-          <a:ln>
-            <a:solidFill>
-              <a:srgbClr val="38545E"/>
-            </a:solidFill>
-          </a:ln>
-        </p:spPr>
-        <p:style>
-          <a:lnRef idx="1">
-            <a:schemeClr val="accent1"/>
-          </a:lnRef>
-          <a:fillRef idx="3">
-            <a:schemeClr val="accent1"/>
-          </a:fillRef>
-          <a:effectRef idx="2">
-            <a:schemeClr val="accent1"/>
-          </a:effectRef>
-          <a:fontRef idx="minor">
-            <a:schemeClr val="lt1"/>
-          </a:fontRef>
-        </p:style>
-        <p:txBody>
-          <a:bodyPr rtlCol="0" anchor="ctr"/>
-          <a:lstStyle/>
-          <a:p>
-            <a:pPr algn="ctr"/>
-          </a:p>
-        </p:txBody>
-      </p:sp>
-      <p:sp>
-        <p:nvSpPr>
-          <p:cNvPr id="15" name="TextBox 14"/>
+              <a:t>What belongs in my meeting brief?
+Up to five developments, their business implications and the sources to verify them.</a:t>
+            </a:r>
+          </a:p>
+        </p:txBody>
+      </p:sp>
+      <p:sp>
+        <p:nvSpPr>
+          <p:cNvPr id="14" name="TextBox 13"/>
           <p:cNvSpPr txBox="1"/>
           <p:nvPr/>
         </p:nvSpPr>
         <p:spPr>
           <a:xfrm>
-            <a:off x="7927848" y="2286000"/>
-            <a:ext cx="1426464" cy="274320"/>
+            <a:off x="777240" y="5577840"/>
+            <a:ext cx="10698480" cy="548640"/>
           </a:xfrm>
           <a:prstGeom prst="rect">
             <a:avLst/>
@@ -3936,198 +3895,13 @@
           <a:p>
             <a:pPr algn="l"/>
             <a:r>
-              <a:rPr sz="900" b="1">
-                <a:solidFill>
-                  <a:srgbClr val="A4D4CD"/>
+              <a:rPr sz="1500" b="0">
+                <a:solidFill>
+                  <a:srgbClr val="F4F1EA"/>
                 </a:solidFill>
                 <a:latin typeface="Aptos"/>
               </a:rPr>
-              <a:t>EXPLAIN</a:t>
-            </a:r>
-          </a:p>
-        </p:txBody>
-      </p:sp>
-      <p:sp>
-        <p:nvSpPr>
-          <p:cNvPr id="16" name="TextBox 15"/>
-          <p:cNvSpPr txBox="1"/>
-          <p:nvPr/>
-        </p:nvSpPr>
-        <p:spPr>
-          <a:xfrm>
-            <a:off x="7927848" y="2724912"/>
-            <a:ext cx="1426464" cy="1965960"/>
-          </a:xfrm>
-          <a:prstGeom prst="rect">
-            <a:avLst/>
-          </a:prstGeom>
-          <a:noFill/>
-        </p:spPr>
-        <p:txBody>
-          <a:bodyPr wrap="square" lIns="18288" rIns="18288" anchor="t">
-            <a:spAutoFit/>
-          </a:bodyPr>
-          <a:lstStyle/>
-          <a:p>
-            <a:pPr algn="l"/>
-            <a:r>
-              <a:rPr sz="1500" b="0">
-                <a:solidFill>
-                  <a:srgbClr val="F4F1EA"/>
-                </a:solidFill>
-                <a:latin typeface="Aptos"/>
-              </a:rPr>
-              <a:t>Separate reported facts from implications</a:t>
-            </a:r>
-          </a:p>
-        </p:txBody>
-      </p:sp>
-      <p:sp>
-        <p:nvSpPr>
-          <p:cNvPr id="17" name="Rectangle 16"/>
-          <p:cNvSpPr/>
-          <p:nvPr/>
-        </p:nvSpPr>
-        <p:spPr>
-          <a:xfrm>
-            <a:off x="10058400" y="2103120"/>
-            <a:ext cx="1828800" cy="2743200"/>
-          </a:xfrm>
-          <a:prstGeom prst="rect">
-            <a:avLst/>
-          </a:prstGeom>
-          <a:solidFill>
-            <a:srgbClr val="193340"/>
-          </a:solidFill>
-          <a:ln>
-            <a:solidFill>
-              <a:srgbClr val="38545E"/>
-            </a:solidFill>
-          </a:ln>
-        </p:spPr>
-        <p:style>
-          <a:lnRef idx="1">
-            <a:schemeClr val="accent1"/>
-          </a:lnRef>
-          <a:fillRef idx="3">
-            <a:schemeClr val="accent1"/>
-          </a:fillRef>
-          <a:effectRef idx="2">
-            <a:schemeClr val="accent1"/>
-          </a:effectRef>
-          <a:fontRef idx="minor">
-            <a:schemeClr val="lt1"/>
-          </a:fontRef>
-        </p:style>
-        <p:txBody>
-          <a:bodyPr rtlCol="0" anchor="ctr"/>
-          <a:lstStyle/>
-          <a:p>
-            <a:pPr algn="ctr"/>
-          </a:p>
-        </p:txBody>
-      </p:sp>
-      <p:sp>
-        <p:nvSpPr>
-          <p:cNvPr id="18" name="TextBox 17"/>
-          <p:cNvSpPr txBox="1"/>
-          <p:nvPr/>
-        </p:nvSpPr>
-        <p:spPr>
-          <a:xfrm>
-            <a:off x="10259568" y="2286000"/>
-            <a:ext cx="1426464" cy="274320"/>
-          </a:xfrm>
-          <a:prstGeom prst="rect">
-            <a:avLst/>
-          </a:prstGeom>
-          <a:noFill/>
-        </p:spPr>
-        <p:txBody>
-          <a:bodyPr wrap="square" lIns="18288" rIns="18288" anchor="t">
-            <a:spAutoFit/>
-          </a:bodyPr>
-          <a:lstStyle/>
-          <a:p>
-            <a:pPr algn="l"/>
-            <a:r>
-              <a:rPr sz="900" b="1">
-                <a:solidFill>
-                  <a:srgbClr val="A4D4CD"/>
-                </a:solidFill>
-                <a:latin typeface="Aptos"/>
-              </a:rPr>
-              <a:t>CHECK</a:t>
-            </a:r>
-          </a:p>
-        </p:txBody>
-      </p:sp>
-      <p:sp>
-        <p:nvSpPr>
-          <p:cNvPr id="19" name="TextBox 18"/>
-          <p:cNvSpPr txBox="1"/>
-          <p:nvPr/>
-        </p:nvSpPr>
-        <p:spPr>
-          <a:xfrm>
-            <a:off x="10259568" y="2724912"/>
-            <a:ext cx="1426464" cy="1965960"/>
-          </a:xfrm>
-          <a:prstGeom prst="rect">
-            <a:avLst/>
-          </a:prstGeom>
-          <a:noFill/>
-        </p:spPr>
-        <p:txBody>
-          <a:bodyPr wrap="square" lIns="18288" rIns="18288" anchor="t">
-            <a:spAutoFit/>
-          </a:bodyPr>
-          <a:lstStyle/>
-          <a:p>
-            <a:pPr algn="l"/>
-            <a:r>
-              <a:rPr sz="1500" b="0">
-                <a:solidFill>
-                  <a:srgbClr val="F4F1EA"/>
-                </a:solidFill>
-                <a:latin typeface="Aptos"/>
-              </a:rPr>
-              <a:t>Open citations and inspect missing evidence</a:t>
-            </a:r>
-          </a:p>
-        </p:txBody>
-      </p:sp>
-      <p:sp>
-        <p:nvSpPr>
-          <p:cNvPr id="20" name="TextBox 19"/>
-          <p:cNvSpPr txBox="1"/>
-          <p:nvPr/>
-        </p:nvSpPr>
-        <p:spPr>
-          <a:xfrm>
-            <a:off x="777240" y="5349240"/>
-            <a:ext cx="10515600" cy="594360"/>
-          </a:xfrm>
-          <a:prstGeom prst="rect">
-            <a:avLst/>
-          </a:prstGeom>
-          <a:noFill/>
-        </p:spPr>
-        <p:txBody>
-          <a:bodyPr wrap="square" lIns="18288" rIns="18288" anchor="t">
-            <a:spAutoFit/>
-          </a:bodyPr>
-          <a:lstStyle/>
-          <a:p>
-            <a:pPr algn="l"/>
-            <a:r>
-              <a:rPr sz="1300" b="0">
-                <a:solidFill>
-                  <a:srgbClr val="AEC8C6"/>
-                </a:solidFill>
-                <a:latin typeface="Aptos"/>
-              </a:rPr>
-              <a:t>z.ai chooses tools • Firecrawl reads sources • FastEmbed + Qdrant retrieves • SQLite preserves observations</a:t>
+              <a:t>Follow the thread: expand a point  →  inspect the evidence  →  compare last quarter  →  decide what to watch</a:t>
             </a:r>
           </a:p>
         </p:txBody>
@@ -4188,7 +3962,7 @@
                 </a:solidFill>
                 <a:latin typeface="Aptos"/>
               </a:rPr>
-              <a:t>LONDON MARKET MONITOR  /  LIVE CHECK  ·  LIVE RESEARCH</a:t>
+              <a:t>LONDON MARKET MONITOR  /  EXAMPLE INVESTIGATION  ·  MARKET INTELLIGENCE</a:t>
             </a:r>
           </a:p>
         </p:txBody>
@@ -4258,7 +4032,7 @@
                 </a:solidFill>
                 <a:latin typeface="Georgia"/>
               </a:rPr>
-              <a:t>A recorded run, with its limits visible</a:t>
+              <a:t>Is West End outperforming City?</a:t>
             </a:r>
           </a:p>
         </p:txBody>
@@ -4271,8 +4045,8 @@
         </p:nvSpPr>
         <p:spPr>
           <a:xfrm>
-            <a:off x="731520" y="1920240"/>
-            <a:ext cx="6400800" cy="3566160"/>
+            <a:off x="731520" y="1965960"/>
+            <a:ext cx="5074920" cy="3611880"/>
           </a:xfrm>
           <a:prstGeom prst="rect">
             <a:avLst/>
@@ -4316,8 +4090,8 @@
         </p:nvSpPr>
         <p:spPr>
           <a:xfrm>
-            <a:off x="932688" y="2103120"/>
-            <a:ext cx="5998464" cy="274320"/>
+            <a:off x="932688" y="2148840"/>
+            <a:ext cx="4672583" cy="274320"/>
           </a:xfrm>
           <a:prstGeom prst="rect">
             <a:avLst/>
@@ -4338,7 +4112,7 @@
                 </a:solidFill>
                 <a:latin typeface="Aptos"/>
               </a:rPr>
-              <a:t>ACTUAL MODEL ANSWER</a:t>
+              <a:t>TEST THE HYPOTHESIS</a:t>
             </a:r>
           </a:p>
         </p:txBody>
@@ -4351,8 +4125,8 @@
         </p:nvSpPr>
         <p:spPr>
           <a:xfrm>
-            <a:off x="932688" y="2542032"/>
-            <a:ext cx="5998464" cy="2788920"/>
+            <a:off x="932688" y="2587752"/>
+            <a:ext cx="4672583" cy="2834640"/>
           </a:xfrm>
           <a:prstGeom prst="rect">
             <a:avLst/>
@@ -4373,8 +4147,11 @@
                 </a:solidFill>
                 <a:latin typeface="Aptos"/>
               </a:rPr>
-              <a:t>Per the stored JLL 'Central London Office Market Dynamics Q2 2026' report, take-up reached 2.6 million sq.ft. in Q2 2026, up 15% quarter-on-quarter and above the 10-year average, led by a strong West End performance.
-Implication: with take-up above its 10-year average while supply shrinks and the construction pipeline thins, occupiers with defined requirements may benefit from starting searches and committing earlier, as choice and negotiating leverage could diminish.</a:t>
+              <a:t>Rents: compare growth, not just rent levels.
+Vacancy: align coverage and Grade A definitions.
+Take-up: compare the same reporting periods.
+Supply: distinguish future space from pre-lets.
+Commentary + macro: look for drivers and counterevidence.</a:t>
             </a:r>
           </a:p>
         </p:txBody>
@@ -4387,8 +4164,8 @@
         </p:nvSpPr>
         <p:spPr>
           <a:xfrm>
-            <a:off x="7498079" y="1920240"/>
-            <a:ext cx="3931920" cy="3566160"/>
+            <a:off x="6217920" y="1965960"/>
+            <a:ext cx="5212080" cy="3611880"/>
           </a:xfrm>
           <a:prstGeom prst="rect">
             <a:avLst/>
@@ -4432,8 +4209,8 @@
         </p:nvSpPr>
         <p:spPr>
           <a:xfrm>
-            <a:off x="7699248" y="2103120"/>
-            <a:ext cx="3529584" cy="274320"/>
+            <a:off x="6419088" y="2148840"/>
+            <a:ext cx="4809744" cy="274320"/>
           </a:xfrm>
           <a:prstGeom prst="rect">
             <a:avLst/>
@@ -4454,7 +4231,7 @@
                 </a:solidFill>
                 <a:latin typeface="Aptos"/>
               </a:rPr>
-              <a:t>EVIDENCE TRAIL</a:t>
+              <a:t>A USEFUL CONCLUSION</a:t>
             </a:r>
           </a:p>
         </p:txBody>
@@ -4467,8 +4244,8 @@
         </p:nvSpPr>
         <p:spPr>
           <a:xfrm>
-            <a:off x="7699248" y="2542032"/>
-            <a:ext cx="3529584" cy="2788920"/>
+            <a:off x="6419088" y="2587752"/>
+            <a:ext cx="4809744" cy="2834640"/>
           </a:xfrm>
           <a:prstGeom prst="rect">
             <a:avLst/>
@@ -4489,11 +4266,9 @@
                 </a:solidFill>
                 <a:latin typeface="Aptos"/>
               </a:rPr>
-              <a:t>1 cited source(s) · incomplete
-search_web
-query_market_metrics
-search_market_evidence
-Directly ingested public report. Local vector check. Firecrawl was not used in this run.</a:t>
+              <a:t>Supported · Partially supported
+Not supported · Insufficient evidence
+Explain which indicators support the claim, which challenge it and what is missing. Keep facts separate from interpretation.</a:t>
             </a:r>
           </a:p>
         </p:txBody>
@@ -4506,8 +4281,8 @@
         </p:nvSpPr>
         <p:spPr>
           <a:xfrm>
-            <a:off x="777240" y="5897880"/>
-            <a:ext cx="10607040" cy="457200"/>
+            <a:off x="777240" y="5806440"/>
+            <a:ext cx="10698480" cy="502920"/>
           </a:xfrm>
           <a:prstGeom prst="rect">
             <a:avLst/>
@@ -4522,13 +4297,13 @@
           <a:p>
             <a:pPr algn="l"/>
             <a:r>
-              <a:rPr sz="1000" b="0">
+              <a:rPr sz="1200" b="0">
                 <a:solidFill>
                   <a:srgbClr val="708087"/>
                 </a:solidFill>
                 <a:latin typeface="Aptos"/>
               </a:rPr>
-              <a:t>Source: https://www.jll.com/en-uk/insights/market-dynamics/central-london-office</a:t>
+              <a:t>Investigation design shown here; this slide does not assert a current market verdict.</a:t>
             </a:r>
           </a:p>
         </p:txBody>
@@ -4589,7 +4364,7 @@
                 </a:solidFill>
                 <a:latin typeface="Aptos"/>
               </a:rPr>
-              <a:t>LONDON MARKET MONITOR  /  CHANGE BRIEFING  ·  LIVE RESEARCH</a:t>
+              <a:t>LONDON MARKET MONITOR  /  TRUST  ·  MARKET INTELLIGENCE</a:t>
             </a:r>
           </a:p>
         </p:txBody>
@@ -4659,7 +4434,7 @@
                 </a:solidFill>
                 <a:latin typeface="Georgia"/>
               </a:rPr>
-              <a:t>Separate a changed market from a changed source</a:t>
+              <a:t>Every important claim has a trail back to evidence.</a:t>
             </a:r>
           </a:p>
         </p:txBody>
@@ -4673,7 +4448,7 @@
         <p:spPr>
           <a:xfrm>
             <a:off x="731520" y="1965960"/>
-            <a:ext cx="4892040" cy="1645920"/>
+            <a:ext cx="4892040" cy="1691640"/>
           </a:xfrm>
           <a:prstGeom prst="rect">
             <a:avLst/>
@@ -4739,7 +4514,7 @@
                 </a:solidFill>
                 <a:latin typeface="Aptos"/>
               </a:rPr>
-              <a:t>NEW REPORT</a:t>
+              <a:t>SHOW THE CALCULATION</a:t>
             </a:r>
           </a:p>
         </p:txBody>
@@ -4753,7 +4528,7 @@
         <p:spPr>
           <a:xfrm>
             <a:off x="932688" y="2587752"/>
-            <a:ext cx="4489703" cy="868680"/>
+            <a:ext cx="4489703" cy="914400"/>
           </a:xfrm>
           <a:prstGeom prst="rect">
             <a:avLst/>
@@ -4774,7 +4549,7 @@
                 </a:solidFill>
                 <a:latin typeface="Aptos"/>
               </a:rPr>
-              <a:t>Discoveries establish coverage; they do not alone prove market movement.</a:t>
+              <a:t>Source values, units and reporting periods alongside derived deltas. Transparent screening thresholds.</a:t>
             </a:r>
           </a:p>
         </p:txBody>
@@ -4788,7 +4563,7 @@
         <p:spPr>
           <a:xfrm>
             <a:off x="6263640" y="1965960"/>
-            <a:ext cx="4892040" cy="1645920"/>
+            <a:ext cx="4892040" cy="1691640"/>
           </a:xfrm>
           <a:prstGeom prst="rect">
             <a:avLst/>
@@ -4854,7 +4629,7 @@
                 </a:solidFill>
                 <a:latin typeface="Aptos"/>
               </a:rPr>
-              <a:t>REVISED CONTENT</a:t>
+              <a:t>KEEP DISAGREEMENT</a:t>
             </a:r>
           </a:p>
         </p:txBody>
@@ -4868,7 +4643,7 @@
         <p:spPr>
           <a:xfrm>
             <a:off x="6464807" y="2587752"/>
-            <a:ext cx="4489703" cy="868680"/>
+            <a:ext cx="4489703" cy="914400"/>
           </a:xfrm>
           <a:prstGeom prst="rect">
             <a:avLst/>
@@ -4889,7 +4664,7 @@
                 </a:solidFill>
                 <a:latin typeface="Aptos"/>
               </a:rPr>
-              <a:t>Same URL, different checksum: retain both versions and source IDs.</a:t>
+              <a:t>Different numbers, definitions or dates remain visible. Conflicting reports are never averaged into one answer.</a:t>
             </a:r>
           </a:p>
         </p:txBody>
@@ -4902,8 +4677,8 @@
         </p:nvSpPr>
         <p:spPr>
           <a:xfrm>
-            <a:off x="731520" y="3749039"/>
-            <a:ext cx="4892040" cy="1645920"/>
+            <a:off x="731520" y="3794760"/>
+            <a:ext cx="4892040" cy="1691640"/>
           </a:xfrm>
           <a:prstGeom prst="rect">
             <a:avLst/>
@@ -4947,7 +4722,7 @@
         </p:nvSpPr>
         <p:spPr>
           <a:xfrm>
-            <a:off x="932688" y="3931920"/>
+            <a:off x="932688" y="3977640"/>
             <a:ext cx="4489703" cy="274320"/>
           </a:xfrm>
           <a:prstGeom prst="rect">
@@ -4969,7 +4744,7 @@
                 </a:solidFill>
                 <a:latin typeface="Aptos"/>
               </a:rPr>
-              <a:t>COMPARABLE CHANGE</a:t>
+              <a:t>EXPLAIN POSSIBLE DRIVERS</a:t>
             </a:r>
           </a:p>
         </p:txBody>
@@ -4982,8 +4757,8 @@
         </p:nvSpPr>
         <p:spPr>
           <a:xfrm>
-            <a:off x="932688" y="4370831"/>
-            <a:ext cx="4489703" cy="868680"/>
+            <a:off x="932688" y="4416552"/>
+            <a:ext cx="4489703" cy="914400"/>
           </a:xfrm>
           <a:prstGeom prst="rect">
             <a:avLst/>
@@ -5004,7 +4779,7 @@
                 </a:solidFill>
                 <a:latin typeface="Aptos"/>
               </a:rPr>
-              <a:t>Match units, periods and definitions; calculate differences in code.</a:t>
+              <a:t>Cited facts are separate from interpretation. Consistency and correlation are not proof of causation.</a:t>
             </a:r>
           </a:p>
         </p:txBody>
@@ -5017,8 +4792,8 @@
         </p:nvSpPr>
         <p:spPr>
           <a:xfrm>
-            <a:off x="6263640" y="3749039"/>
-            <a:ext cx="4892040" cy="1645920"/>
+            <a:off x="6263640" y="3794760"/>
+            <a:ext cx="4892040" cy="1691640"/>
           </a:xfrm>
           <a:prstGeom prst="rect">
             <a:avLst/>
@@ -5062,7 +4837,7 @@
         </p:nvSpPr>
         <p:spPr>
           <a:xfrm>
-            <a:off x="6464807" y="3931920"/>
+            <a:off x="6464807" y="3977640"/>
             <a:ext cx="4489703" cy="274320"/>
           </a:xfrm>
           <a:prstGeom prst="rect">
@@ -5084,7 +4859,7 @@
                 </a:solidFill>
                 <a:latin typeface="Aptos"/>
               </a:rPr>
-              <a:t>BUSINESS IMPLICATION</a:t>
+              <a:t>MAKE VERIFICATION QUICK</a:t>
             </a:r>
           </a:p>
         </p:txBody>
@@ -5097,8 +4872,8 @@
         </p:nvSpPr>
         <p:spPr>
           <a:xfrm>
-            <a:off x="6464807" y="4370831"/>
-            <a:ext cx="4489703" cy="868680"/>
+            <a:off x="6464807" y="4416552"/>
+            <a:ext cx="4489703" cy="914400"/>
           </a:xfrm>
           <a:prstGeom prst="rect">
             <a:avLst/>
@@ -5119,7 +4894,7 @@
                 </a:solidFill>
                 <a:latin typeface="Aptos"/>
               </a:rPr>
-              <a:t>Qualify timing and supply risks; expose disagreement and collection gaps.</a:t>
+              <a:t>Open the publisher, title, date, URL and relevant passage. Missing evidence stays visible, including unsupported forecasts.</a:t>
             </a:r>
           </a:p>
         </p:txBody>
@@ -5180,7 +4955,7 @@
                 </a:solidFill>
                 <a:latin typeface="Aptos"/>
               </a:rPr>
-              <a:t>LONDON MARKET MONITOR  /  READINESS  ·  LIVE RESEARCH</a:t>
+              <a:t>LONDON MARKET MONITOR  /  FROM POC TO PRACTICE  ·  MARKET INTELLIGENCE</a:t>
             </a:r>
           </a:p>
         </p:txBody>
@@ -5250,7 +5025,7 @@
                 </a:solidFill>
                 <a:latin typeface="Georgia"/>
               </a:rPr>
-              <a:t>Implemented; full live readiness still needs verification</a:t>
+              <a:t>Prove the research workflow. Then automate it.</a:t>
             </a:r>
           </a:p>
         </p:txBody>
@@ -5263,8 +5038,8 @@
         </p:nvSpPr>
         <p:spPr>
           <a:xfrm>
-            <a:off x="731520" y="1920240"/>
-            <a:ext cx="3337560" cy="3474720"/>
+            <a:off x="731520" y="1965960"/>
+            <a:ext cx="3337560" cy="3566160"/>
           </a:xfrm>
           <a:prstGeom prst="rect">
             <a:avLst/>
@@ -5308,7 +5083,7 @@
         </p:nvSpPr>
         <p:spPr>
           <a:xfrm>
-            <a:off x="932688" y="2103120"/>
+            <a:off x="932688" y="2148840"/>
             <a:ext cx="2935224" cy="274320"/>
           </a:xfrm>
           <a:prstGeom prst="rect">
@@ -5330,7 +5105,7 @@
                 </a:solidFill>
                 <a:latin typeface="Aptos"/>
               </a:rPr>
-              <a:t>DELIVERED</a:t>
+              <a:t>POC TODAY</a:t>
             </a:r>
           </a:p>
         </p:txBody>
@@ -5343,8 +5118,8 @@
         </p:nvSpPr>
         <p:spPr>
           <a:xfrm>
-            <a:off x="932688" y="2542032"/>
-            <a:ext cx="2935224" cy="2697479"/>
+            <a:off x="932688" y="2587752"/>
+            <a:ext cx="2935224" cy="2788920"/>
           </a:xfrm>
           <a:prstGeom prst="rect">
             <a:avLst/>
@@ -5365,11 +5140,11 @@
                 </a:solidFill>
                 <a:latin typeface="Aptos"/>
               </a:rPr>
-              <a:t>Tool-driven chat
-Semantic evidence
-Manual refresh + briefing
-Source versions + citations
-Explicit demo isolation</a:t>
+              <a:t>On-demand market briefs
+Hypothesis investigations
+Source-backed watchlists
+Manual evidence refresh
+Implications to investigate, not investment recommendations.</a:t>
             </a:r>
           </a:p>
         </p:txBody>
@@ -5382,8 +5157,8 @@
         </p:nvSpPr>
         <p:spPr>
           <a:xfrm>
-            <a:off x="4434840" y="1920240"/>
-            <a:ext cx="3337560" cy="3474720"/>
+            <a:off x="4434840" y="1965960"/>
+            <a:ext cx="3337560" cy="3566160"/>
           </a:xfrm>
           <a:prstGeom prst="rect">
             <a:avLst/>
@@ -5427,7 +5202,7 @@
         </p:nvSpPr>
         <p:spPr>
           <a:xfrm>
-            <a:off x="4636007" y="2103120"/>
+            <a:off x="4636007" y="2148840"/>
             <a:ext cx="2935224" cy="274320"/>
           </a:xfrm>
           <a:prstGeom prst="rect">
@@ -5449,7 +5224,7 @@
                 </a:solidFill>
                 <a:latin typeface="Aptos"/>
               </a:rPr>
-              <a:t>VERIFIED</a:t>
+              <a:t>MEASURE THE VALUE</a:t>
             </a:r>
           </a:p>
         </p:txBody>
@@ -5462,8 +5237,8 @@
         </p:nvSpPr>
         <p:spPr>
           <a:xfrm>
-            <a:off x="4636007" y="2542032"/>
-            <a:ext cx="2935224" cy="2697479"/>
+            <a:off x="4636007" y="2587752"/>
+            <a:ext cx="2935224" cy="2788920"/>
           </a:xfrm>
           <a:prstGeom prst="rect">
             <a:avLst/>
@@ -5484,11 +5259,11 @@
                 </a:solidFill>
                 <a:latin typeface="Aptos"/>
               </a:rPr>
-              <a:t>Automated grounding tests
-Deterministic evaluation
-Real model tool calls
-Real semantic retrieval
-Compose configuration</a:t>
+              <a:t>Time to a usable meeting brief
+Time to verify a claim
+Material developments found
+Missing or disputed evidence exposed
+Compare with the team's manual research baseline; no savings are claimed yet.</a:t>
             </a:r>
           </a:p>
         </p:txBody>
@@ -5501,8 +5276,8 @@
         </p:nvSpPr>
         <p:spPr>
           <a:xfrm>
-            <a:off x="8138160" y="1920240"/>
-            <a:ext cx="3337560" cy="3474720"/>
+            <a:off x="8138160" y="1965960"/>
+            <a:ext cx="3337560" cy="3566160"/>
           </a:xfrm>
           <a:prstGeom prst="rect">
             <a:avLst/>
@@ -5546,7 +5321,7 @@
         </p:nvSpPr>
         <p:spPr>
           <a:xfrm>
-            <a:off x="8339328" y="2103120"/>
+            <a:off x="8339328" y="2148840"/>
             <a:ext cx="2935224" cy="274320"/>
           </a:xfrm>
           <a:prstGeom prst="rect">
@@ -5568,7 +5343,7 @@
                 </a:solidFill>
                 <a:latin typeface="Aptos"/>
               </a:rPr>
-              <a:t>REMAINING BLOCKER</a:t>
+              <a:t>NEXT, AFTER VALIDATION</a:t>
             </a:r>
           </a:p>
         </p:txBody>
@@ -5581,8 +5356,8 @@
         </p:nvSpPr>
         <p:spPr>
           <a:xfrm>
-            <a:off x="8339328" y="2542032"/>
-            <a:ext cx="2935224" cy="2697479"/>
+            <a:off x="8339328" y="2587752"/>
+            <a:ext cx="2935224" cy="2788920"/>
           </a:xfrm>
           <a:prstGeom prst="rect">
             <a:avLst/>
@@ -5603,8 +5378,11 @@
                 </a:solidFill>
                 <a:latin typeface="Aptos"/>
               </a:rPr>
-              <a:t>Free host disk capacity and restore Docker health.
-Then verify Firecrawl search + scrape, full Compose startup and persistence.</a:t>
+              <a:t>Automated monitoring
+Material-change alerts
+Private reports and leasing data
+Team-specific watchlists
+Prioritize additions using observed workflow needs.</a:t>
             </a:r>
           </a:p>
         </p:txBody>

</xml_diff>